<commit_message>
Add encrypted SMB3 printer delivery and prepare beta.3 release
</commit_message>
<xml_diff>
--- a/docs/presentation/GoPrint-Product.pptx
+++ b/docs/presentation/GoPrint-Product.pptx
@@ -2,34 +2,35 @@
 <file path=ppt/presentation.xml><?xml version="1.0" encoding="utf-8"?>
 <p:presentation xmlns:p="http://schemas.openxmlformats.org/presentationml/2006/main">
   <p:sldMasterIdLst>
-    <p:sldMasterId xmlns:r="http://schemas.openxmlformats.org/officeDocument/2006/relationships" id="2147483648" r:id="R5f95d31df7204c5f"/>
+    <p:sldMasterId xmlns:r="http://schemas.openxmlformats.org/officeDocument/2006/relationships" id="2147483648" r:id="R834816e235e7460e"/>
   </p:sldMasterIdLst>
   <p:notesMasterIdLst>
-    <p:notesMasterId xmlns:r="http://schemas.openxmlformats.org/officeDocument/2006/relationships" r:id="Ra659170fae4043b0"/>
+    <p:notesMasterId xmlns:r="http://schemas.openxmlformats.org/officeDocument/2006/relationships" r:id="Rc419165b47994cc8"/>
   </p:notesMasterIdLst>
   <p:sldIdLst>
-    <p:sldId xmlns:r="http://schemas.openxmlformats.org/officeDocument/2006/relationships" id="256" r:id="R7d5c6f7565714714"/>
-    <p:sldId xmlns:r="http://schemas.openxmlformats.org/officeDocument/2006/relationships" id="257" r:id="Rb0ae608df186424c"/>
-    <p:sldId xmlns:r="http://schemas.openxmlformats.org/officeDocument/2006/relationships" id="258" r:id="R64a7273e444d4535"/>
-    <p:sldId xmlns:r="http://schemas.openxmlformats.org/officeDocument/2006/relationships" id="259" r:id="R3f6bca097272437b"/>
-    <p:sldId xmlns:r="http://schemas.openxmlformats.org/officeDocument/2006/relationships" id="260" r:id="R7131097800d541ec"/>
-    <p:sldId xmlns:r="http://schemas.openxmlformats.org/officeDocument/2006/relationships" id="261" r:id="R80854d0778de45ab"/>
-    <p:sldId xmlns:r="http://schemas.openxmlformats.org/officeDocument/2006/relationships" id="262" r:id="Rdbd59c096e2d46f5"/>
-    <p:sldId xmlns:r="http://schemas.openxmlformats.org/officeDocument/2006/relationships" id="263" r:id="R3659edc5e91e4400"/>
-    <p:sldId xmlns:r="http://schemas.openxmlformats.org/officeDocument/2006/relationships" id="264" r:id="Rea5fe021ff954749"/>
-    <p:sldId xmlns:r="http://schemas.openxmlformats.org/officeDocument/2006/relationships" id="265" r:id="R90c3797438f448a2"/>
-    <p:sldId xmlns:r="http://schemas.openxmlformats.org/officeDocument/2006/relationships" id="266" r:id="R91f791ad9d754bf9"/>
-    <p:sldId xmlns:r="http://schemas.openxmlformats.org/officeDocument/2006/relationships" id="267" r:id="R48e3907396214881"/>
-    <p:sldId xmlns:r="http://schemas.openxmlformats.org/officeDocument/2006/relationships" id="268" r:id="R9e8bbf1b411d4979"/>
-    <p:sldId xmlns:r="http://schemas.openxmlformats.org/officeDocument/2006/relationships" id="269" r:id="Rdb2e14c786ef48fd"/>
-    <p:sldId xmlns:r="http://schemas.openxmlformats.org/officeDocument/2006/relationships" id="270" r:id="R3709957d86844525"/>
-    <p:sldId xmlns:r="http://schemas.openxmlformats.org/officeDocument/2006/relationships" id="271" r:id="R7e316890b2eb48db"/>
-    <p:sldId xmlns:r="http://schemas.openxmlformats.org/officeDocument/2006/relationships" id="272" r:id="Rf0b1cb99c6b3482a"/>
-    <p:sldId xmlns:r="http://schemas.openxmlformats.org/officeDocument/2006/relationships" id="273" r:id="R47f5729c48c046dd"/>
-    <p:sldId xmlns:r="http://schemas.openxmlformats.org/officeDocument/2006/relationships" id="274" r:id="R45895f888ed44803"/>
-    <p:sldId xmlns:r="http://schemas.openxmlformats.org/officeDocument/2006/relationships" id="275" r:id="R51350bf622384a32"/>
-    <p:sldId xmlns:r="http://schemas.openxmlformats.org/officeDocument/2006/relationships" id="276" r:id="R46c8f355e7184ef8"/>
-    <p:sldId xmlns:r="http://schemas.openxmlformats.org/officeDocument/2006/relationships" id="277" r:id="R029b86177ea94b58"/>
+    <p:sldId xmlns:r="http://schemas.openxmlformats.org/officeDocument/2006/relationships" id="256" r:id="Rc0a90038a2f04f76"/>
+    <p:sldId xmlns:r="http://schemas.openxmlformats.org/officeDocument/2006/relationships" id="257" r:id="R170e519e968e400b"/>
+    <p:sldId xmlns:r="http://schemas.openxmlformats.org/officeDocument/2006/relationships" id="258" r:id="R71290349abea4356"/>
+    <p:sldId xmlns:r="http://schemas.openxmlformats.org/officeDocument/2006/relationships" id="259" r:id="Rd4089578c40d42c2"/>
+    <p:sldId xmlns:r="http://schemas.openxmlformats.org/officeDocument/2006/relationships" id="260" r:id="R3e5e07e45d884b6e"/>
+    <p:sldId xmlns:r="http://schemas.openxmlformats.org/officeDocument/2006/relationships" id="261" r:id="R5fddd2fd38004008"/>
+    <p:sldId xmlns:r="http://schemas.openxmlformats.org/officeDocument/2006/relationships" id="262" r:id="R7ac46cbc28bd45ec"/>
+    <p:sldId xmlns:r="http://schemas.openxmlformats.org/officeDocument/2006/relationships" id="263" r:id="R9ee68f93bafc442e"/>
+    <p:sldId xmlns:r="http://schemas.openxmlformats.org/officeDocument/2006/relationships" id="264" r:id="R94c4588460014706"/>
+    <p:sldId xmlns:r="http://schemas.openxmlformats.org/officeDocument/2006/relationships" id="265" r:id="R55432c297aa34258"/>
+    <p:sldId xmlns:r="http://schemas.openxmlformats.org/officeDocument/2006/relationships" id="266" r:id="R2e48d02c0a6b4d73"/>
+    <p:sldId xmlns:r="http://schemas.openxmlformats.org/officeDocument/2006/relationships" id="267" r:id="Rdaaa2ff6d98d42e9"/>
+    <p:sldId xmlns:r="http://schemas.openxmlformats.org/officeDocument/2006/relationships" id="268" r:id="Rdbaf3f4ae70e4d14"/>
+    <p:sldId xmlns:r="http://schemas.openxmlformats.org/officeDocument/2006/relationships" id="269" r:id="R246d92f9c42e4ec0"/>
+    <p:sldId xmlns:r="http://schemas.openxmlformats.org/officeDocument/2006/relationships" id="270" r:id="R66aa377e7e544293"/>
+    <p:sldId xmlns:r="http://schemas.openxmlformats.org/officeDocument/2006/relationships" id="271" r:id="Re0ffa4dd7a494847"/>
+    <p:sldId xmlns:r="http://schemas.openxmlformats.org/officeDocument/2006/relationships" id="272" r:id="R204f850c4b924664"/>
+    <p:sldId xmlns:r="http://schemas.openxmlformats.org/officeDocument/2006/relationships" id="273" r:id="R9733d97527c642fa"/>
+    <p:sldId xmlns:r="http://schemas.openxmlformats.org/officeDocument/2006/relationships" id="274" r:id="R09371edfafd14d57"/>
+    <p:sldId xmlns:r="http://schemas.openxmlformats.org/officeDocument/2006/relationships" id="275" r:id="Ra8c01338dcf74fb6"/>
+    <p:sldId xmlns:r="http://schemas.openxmlformats.org/officeDocument/2006/relationships" id="276" r:id="R96e0b606d46945ff"/>
+    <p:sldId xmlns:r="http://schemas.openxmlformats.org/officeDocument/2006/relationships" id="277" r:id="Rc048035b665e4903"/>
+    <p:sldId xmlns:r="http://schemas.openxmlformats.org/officeDocument/2006/relationships" id="278" r:id="Ra48d0fda97e1412d"/>
   </p:sldIdLst>
   <p:sldSz cx="12192000" cy="6858000"/>
   <p:notesSz cx="6858000" cy="9144000"/>
@@ -463,7 +464,7 @@
           <a:lstStyle xmlns:a="http://schemas.openxmlformats.org/drawingml/2006/main"/>
           <a:p xmlns:a="http://schemas.openxmlformats.org/drawingml/2006/main">
             <a:r>
-              <a:t>GoPrint — сервер печати и приёма сканов на Go. Реализованные возможности beta.2 и условия пилота. Источник: https://github.com/rkislov/goPrint/tree/main</a:t>
+              <a:t>GoPrint — сервер печати и приёма сканов на Go. Реализованные возможности продукта и условия пилота. Источник: https://github.com/rkislov/goPrint/tree/main</a:t>
             </a:r>
           </a:p>
         </p:txBody>
@@ -1553,6 +1554,76 @@
           <a:lstStyle xmlns:a="http://schemas.openxmlformats.org/drawingml/2006/main"/>
           <a:p xmlns:a="http://schemas.openxmlformats.org/drawingml/2006/main">
             <a:r>
+              <a:t>Исходящий SMB проверен на Samba 4.20.6 с обязательным SMB3-шифрованием. Удалённый сервер видит служебную запись. Входящий мост проверен с синтетическим resolver. Реальный AD/Windows и физический принтер требуют пилота. Point and Print и lpq/lprm не поставляются. submitted подтверждает передачу, а не выход бумаги. Справочник: https://www.samba.org/samba/docs/current/man-html/smbclient.1.html</a:t>
+            </a:r>
+          </a:p>
+        </p:txBody>
+      </p:sp>
+      <p:sp>
+        <p:nvSpPr>
+          <p:cNvPr id="4" name="Slide Number Placeholder 3"/>
+          <p:cNvSpPr>
+            <a:spLocks xmlns:a="http://schemas.openxmlformats.org/drawingml/2006/main" noGrp="1"/>
+          </p:cNvSpPr>
+          <p:nvPr>
+            <p:ph type="sldNum" idx="5"/>
+          </p:nvPr>
+        </p:nvSpPr>
+        <p:spPr/>
+        <p:txBody>
+          <a:bodyPr xmlns:a="http://schemas.openxmlformats.org/drawingml/2006/main"/>
+          <a:lstStyle xmlns:a="http://schemas.openxmlformats.org/drawingml/2006/main"/>
+          <a:p xmlns:a="http://schemas.openxmlformats.org/drawingml/2006/main"/>
+        </p:txBody>
+      </p:sp>
+    </p:spTree>
+  </p:cSld>
+  <p:clrMapOvr>
+    <a:masterClrMapping xmlns:a="http://schemas.openxmlformats.org/drawingml/2006/main"/>
+  </p:clrMapOvr>
+</p:notes>
+</file>
+
+<file path=ppt/notesSlides/notesSlide22.xml><?xml version="1.0" encoding="utf-8"?>
+<p:notes xmlns:p="http://schemas.openxmlformats.org/presentationml/2006/main">
+  <p:cSld>
+    <p:spTree>
+      <p:nvGrpSpPr>
+        <p:cNvPr id="1" name=""/>
+        <p:cNvGrpSpPr/>
+        <p:nvPr/>
+      </p:nvGrpSpPr>
+      <p:grpSpPr>
+        <a:xfrm xmlns:a="http://schemas.openxmlformats.org/drawingml/2006/main"/>
+      </p:grpSpPr>
+      <p:sp>
+        <p:nvSpPr>
+          <p:cNvPr id="2" name="Slide Image Placeholder 1"/>
+          <p:cNvSpPr>
+            <a:spLocks xmlns:a="http://schemas.openxmlformats.org/drawingml/2006/main" noGrp="1"/>
+          </p:cNvSpPr>
+          <p:nvPr>
+            <p:ph type="sldImg" idx="0"/>
+          </p:nvPr>
+        </p:nvSpPr>
+        <p:spPr/>
+      </p:sp>
+      <p:sp>
+        <p:nvSpPr>
+          <p:cNvPr id="3" name="Notes Placeholder 2"/>
+          <p:cNvSpPr>
+            <a:spLocks xmlns:a="http://schemas.openxmlformats.org/drawingml/2006/main" noGrp="1"/>
+          </p:cNvSpPr>
+          <p:nvPr>
+            <p:ph type="body" idx="1"/>
+          </p:nvPr>
+        </p:nvSpPr>
+        <p:spPr/>
+        <p:txBody>
+          <a:bodyPr xmlns:a="http://schemas.openxmlformats.org/drawingml/2006/main"/>
+          <a:lstStyle xmlns:a="http://schemas.openxmlformats.org/drawingml/2006/main"/>
+          <a:p xmlns:a="http://schemas.openxmlformats.org/drawingml/2006/main">
+            <a:r>
               <a:t>Физическая совместимость и реальные AD/Windows/SNMPv3 не подтверждены аппаратным пилотом. В продукте нет SMB/USB, NTLM, WSD/автообнаружения сканеров и отдельного приложения панели МФУ. FTP не сообщает ожидаемую длину STOR: маркеры не доказывают полноту всех страниц. WebDAV MOVE/LOCK, implicit FTPS и SFTP не поддерживаются. Высокая доступность, нагрузочная ёмкость и SLA не заявлены. Это существенные условия оценки продукта, а не внутренний план разработки.</a:t>
             </a:r>
           </a:p>
@@ -1598,7 +1669,7 @@
 </p:notes>
 </file>
 
-<file path=ppt/notesSlides/notesSlide22.xml><?xml version="1.0" encoding="utf-8"?>
+<file path=ppt/notesSlides/notesSlide23.xml><?xml version="1.0" encoding="utf-8"?>
 <p:notes xmlns:p="http://schemas.openxmlformats.org/presentationml/2006/main">
   <p:cSld>
     <p:spTree>
@@ -4661,12 +4732,12 @@
   </p:cSld>
   <p:clrMap bg1="lt1" tx1="dk1" bg2="lt2" tx2="dk2" accent1="accent1" accent2="accent2" accent3="accent3" accent4="accent4" accent5="accent5" accent6="accent6" hlink="hlink" folHlink="folHlink"/>
   <p:sldLayoutIdLst>
-    <p:sldLayoutId xmlns:r="http://schemas.openxmlformats.org/officeDocument/2006/relationships" id="2147483649" r:id="Rc556be7975314f44"/>
-    <p:sldLayoutId xmlns:r="http://schemas.openxmlformats.org/officeDocument/2006/relationships" id="2147483650" r:id="Ra0b9e8a701874713"/>
-    <p:sldLayoutId xmlns:r="http://schemas.openxmlformats.org/officeDocument/2006/relationships" id="2147483651" r:id="Rc3575af75619480b"/>
-    <p:sldLayoutId xmlns:r="http://schemas.openxmlformats.org/officeDocument/2006/relationships" id="2147483652" r:id="R4008f7ea11844bd1"/>
-    <p:sldLayoutId xmlns:r="http://schemas.openxmlformats.org/officeDocument/2006/relationships" id="2147483653" r:id="Re8a4c0ed1af94c67"/>
-    <p:sldLayoutId xmlns:r="http://schemas.openxmlformats.org/officeDocument/2006/relationships" id="2147483654" r:id="R14c96a17948347d2"/>
+    <p:sldLayoutId xmlns:r="http://schemas.openxmlformats.org/officeDocument/2006/relationships" id="2147483649" r:id="Rb4e5544005ab41c6"/>
+    <p:sldLayoutId xmlns:r="http://schemas.openxmlformats.org/officeDocument/2006/relationships" id="2147483650" r:id="Ra6b7be05a8a345e7"/>
+    <p:sldLayoutId xmlns:r="http://schemas.openxmlformats.org/officeDocument/2006/relationships" id="2147483651" r:id="R774d681aae5c477f"/>
+    <p:sldLayoutId xmlns:r="http://schemas.openxmlformats.org/officeDocument/2006/relationships" id="2147483652" r:id="R9de00786462349f0"/>
+    <p:sldLayoutId xmlns:r="http://schemas.openxmlformats.org/officeDocument/2006/relationships" id="2147483653" r:id="R8721de43c0c049f7"/>
+    <p:sldLayoutId xmlns:r="http://schemas.openxmlformats.org/officeDocument/2006/relationships" id="2147483654" r:id="Rae69718d977045f8"/>
   </p:sldLayoutIdLst>
   <p:txStyles>
     <p:titleStyle>
@@ -6353,7 +6424,7 @@
           <p:nvPr/>
         </p:nvPicPr>
         <p:blipFill>
-          <a:blip xmlns:r="http://schemas.openxmlformats.org/officeDocument/2006/relationships" xmlns:a="http://schemas.openxmlformats.org/drawingml/2006/main" r:embed="R857a7d33fcd34610"/>
+          <a:blip xmlns:r="http://schemas.openxmlformats.org/officeDocument/2006/relationships" xmlns:a="http://schemas.openxmlformats.org/drawingml/2006/main" r:embed="R0e7a2708d28f4d16"/>
           <a:stretch xmlns:a="http://schemas.openxmlformats.org/drawingml/2006/main"/>
         </p:blipFill>
         <p:spPr>
@@ -7130,7 +7201,7 @@
           <p:nvPr/>
         </p:nvPicPr>
         <p:blipFill>
-          <a:blip xmlns:r="http://schemas.openxmlformats.org/officeDocument/2006/relationships" xmlns:a="http://schemas.openxmlformats.org/drawingml/2006/main" r:embed="Rdb0ea3a54db54b32"/>
+          <a:blip xmlns:r="http://schemas.openxmlformats.org/officeDocument/2006/relationships" xmlns:a="http://schemas.openxmlformats.org/drawingml/2006/main" r:embed="R5a337ab7f25d45fd"/>
           <a:stretch xmlns:a="http://schemas.openxmlformats.org/drawingml/2006/main"/>
         </p:blipFill>
         <p:spPr>
@@ -7787,7 +7858,7 @@
           <p:nvPr/>
         </p:nvPicPr>
         <p:blipFill>
-          <a:blip xmlns:r="http://schemas.openxmlformats.org/officeDocument/2006/relationships" xmlns:a="http://schemas.openxmlformats.org/drawingml/2006/main" r:embed="R75174ac8d4064a05"/>
+          <a:blip xmlns:r="http://schemas.openxmlformats.org/officeDocument/2006/relationships" xmlns:a="http://schemas.openxmlformats.org/drawingml/2006/main" r:embed="Rc237699b7a254a16"/>
           <a:stretch xmlns:a="http://schemas.openxmlformats.org/drawingml/2006/main"/>
         </p:blipFill>
         <p:spPr>
@@ -8564,7 +8635,7 @@
           <p:nvPr/>
         </p:nvPicPr>
         <p:blipFill>
-          <a:blip xmlns:r="http://schemas.openxmlformats.org/officeDocument/2006/relationships" xmlns:a="http://schemas.openxmlformats.org/drawingml/2006/main" r:embed="R165f5e693d90440f"/>
+          <a:blip xmlns:r="http://schemas.openxmlformats.org/officeDocument/2006/relationships" xmlns:a="http://schemas.openxmlformats.org/drawingml/2006/main" r:embed="R7540a035a7ab44c3"/>
           <a:stretch xmlns:a="http://schemas.openxmlformats.org/drawingml/2006/main"/>
         </p:blipFill>
         <p:spPr>
@@ -9221,7 +9292,7 @@
           <p:nvPr/>
         </p:nvPicPr>
         <p:blipFill>
-          <a:blip xmlns:r="http://schemas.openxmlformats.org/officeDocument/2006/relationships" xmlns:a="http://schemas.openxmlformats.org/drawingml/2006/main" r:embed="R561f04b1031545cf"/>
+          <a:blip xmlns:r="http://schemas.openxmlformats.org/officeDocument/2006/relationships" xmlns:a="http://schemas.openxmlformats.org/drawingml/2006/main" r:embed="R73a22d32e2fc42f1"/>
           <a:stretch xmlns:a="http://schemas.openxmlformats.org/drawingml/2006/main"/>
         </p:blipFill>
         <p:spPr>
@@ -9998,7 +10069,7 @@
           <p:nvPr/>
         </p:nvPicPr>
         <p:blipFill>
-          <a:blip xmlns:r="http://schemas.openxmlformats.org/officeDocument/2006/relationships" xmlns:a="http://schemas.openxmlformats.org/drawingml/2006/main" r:embed="R61fbb5f034dd49fd"/>
+          <a:blip xmlns:r="http://schemas.openxmlformats.org/officeDocument/2006/relationships" xmlns:a="http://schemas.openxmlformats.org/drawingml/2006/main" r:embed="R22fd59916e7c443c"/>
           <a:stretch xmlns:a="http://schemas.openxmlformats.org/drawingml/2006/main"/>
         </p:blipFill>
         <p:spPr>
@@ -10535,7 +10606,7 @@
           <p:nvPr/>
         </p:nvPicPr>
         <p:blipFill>
-          <a:blip xmlns:r="http://schemas.openxmlformats.org/officeDocument/2006/relationships" xmlns:a="http://schemas.openxmlformats.org/drawingml/2006/main" r:embed="R694c087ae07e4ede"/>
+          <a:blip xmlns:r="http://schemas.openxmlformats.org/officeDocument/2006/relationships" xmlns:a="http://schemas.openxmlformats.org/drawingml/2006/main" r:embed="Raedbcbc18a5f45a9"/>
           <a:srcRect xmlns:a="http://schemas.openxmlformats.org/drawingml/2006/main" l="0" t="0" r="0" b="0"/>
           <a:stretch xmlns:a="http://schemas.openxmlformats.org/drawingml/2006/main"/>
         </p:blipFill>
@@ -10564,7 +10635,7 @@
           <p:nvPr/>
         </p:nvPicPr>
         <p:blipFill>
-          <a:blip xmlns:r="http://schemas.openxmlformats.org/officeDocument/2006/relationships" xmlns:a="http://schemas.openxmlformats.org/drawingml/2006/main" r:embed="R05d2b9bbba9340cc"/>
+          <a:blip xmlns:r="http://schemas.openxmlformats.org/officeDocument/2006/relationships" xmlns:a="http://schemas.openxmlformats.org/drawingml/2006/main" r:embed="Ra6ae8c61dac44cc5"/>
           <a:srcRect xmlns:a="http://schemas.openxmlformats.org/drawingml/2006/main" l="0" t="0" r="0" b="0"/>
           <a:stretch xmlns:a="http://schemas.openxmlformats.org/drawingml/2006/main"/>
         </p:blipFill>
@@ -11496,7 +11567,7 @@
           <p:nvPr/>
         </p:nvPicPr>
         <p:blipFill>
-          <a:blip xmlns:r="http://schemas.openxmlformats.org/officeDocument/2006/relationships" xmlns:a="http://schemas.openxmlformats.org/drawingml/2006/main" r:embed="R9f9073c9315a4860"/>
+          <a:blip xmlns:r="http://schemas.openxmlformats.org/officeDocument/2006/relationships" xmlns:a="http://schemas.openxmlformats.org/drawingml/2006/main" r:embed="Rbf56096b603a41a5"/>
           <a:srcRect xmlns:a="http://schemas.openxmlformats.org/drawingml/2006/main" l="0" t="0" r="0" b="0"/>
           <a:stretch xmlns:a="http://schemas.openxmlformats.org/drawingml/2006/main"/>
         </p:blipFill>
@@ -12274,7 +12345,7 @@
           <p:nvPr/>
         </p:nvPicPr>
         <p:blipFill>
-          <a:blip xmlns:r="http://schemas.openxmlformats.org/officeDocument/2006/relationships" xmlns:a="http://schemas.openxmlformats.org/drawingml/2006/main" r:embed="Rb697db752a9044de"/>
+          <a:blip xmlns:r="http://schemas.openxmlformats.org/officeDocument/2006/relationships" xmlns:a="http://schemas.openxmlformats.org/drawingml/2006/main" r:embed="R8e358a3ff2ce4ab5"/>
           <a:stretch xmlns:a="http://schemas.openxmlformats.org/drawingml/2006/main"/>
         </p:blipFill>
         <p:spPr>
@@ -12911,7 +12982,7 @@
                   <a:srgbClr val="203D36"/>
                 </a:solidFill>
               </a:rPr>
-              <a:t>Пять бинарников · systemd · HTTPS</a:t>
+              <a:t>Шесть бинарников · systemd · HTTPS</a:t>
             </a:r>
           </a:p>
         </p:txBody>
@@ -14091,7 +14162,7 @@
           <p:nvPr/>
         </p:nvPicPr>
         <p:blipFill>
-          <a:blip xmlns:r="http://schemas.openxmlformats.org/officeDocument/2006/relationships" xmlns:a="http://schemas.openxmlformats.org/drawingml/2006/main" r:embed="R926b08ee444f4eb6"/>
+          <a:blip xmlns:r="http://schemas.openxmlformats.org/officeDocument/2006/relationships" xmlns:a="http://schemas.openxmlformats.org/drawingml/2006/main" r:embed="Rcd400c0388a04c1c"/>
           <a:srcRect xmlns:a="http://schemas.openxmlformats.org/drawingml/2006/main" l="0" t="0" r="0" b="0"/>
           <a:stretch xmlns:a="http://schemas.openxmlformats.org/drawingml/2006/main"/>
         </p:blipFill>
@@ -15845,6 +15916,988 @@
       </p:grpSpPr>
       <p:sp>
         <p:nvSpPr>
+          <p:cNvPr id="9" name="">
+            <a:extLst xmlns:a="http://schemas.openxmlformats.org/drawingml/2006/main">
+              <a:ext uri="{FF2B5EF4-FFF2-40B4-BE49-F238E27FC236}">
+                <a16:creationId xmlns:a16="http://schemas.microsoft.com/office/drawing/2014/main" id="{B5B1E6ED-56D6-4A02-8932-8AA7BA3102F6}"/>
+              </a:ext>
+            </a:extLst>
+          </p:cNvPr>
+          <p:cNvSpPr>
+            <a:spLocks xmlns:a="http://schemas.openxmlformats.org/drawingml/2006/main" noGrp="1"/>
+          </p:cNvSpPr>
+          <p:nvPr/>
+        </p:nvSpPr>
+        <p:spPr>
+          <a:xfrm xmlns:a="http://schemas.openxmlformats.org/drawingml/2006/main">
+            <a:off x="685800" y="495300"/>
+            <a:ext cx="10763250" cy="857250"/>
+          </a:xfrm>
+          <a:prstGeom xmlns:a="http://schemas.openxmlformats.org/drawingml/2006/main" prst="rect">
+            <a:avLst/>
+          </a:prstGeom>
+          <a:noFill xmlns:a="http://schemas.openxmlformats.org/drawingml/2006/main"/>
+          <a:ln xmlns:a="http://schemas.openxmlformats.org/drawingml/2006/main" w="0">
+            <a:noFill/>
+          </a:ln>
+        </p:spPr>
+        <p:txBody>
+          <a:bodyPr xmlns:a="http://schemas.openxmlformats.org/drawingml/2006/main"/>
+          <a:lstStyle xmlns:a="http://schemas.openxmlformats.org/drawingml/2006/main">
+            <a:defPPr>
+              <a:defRPr sz="3600" b="1">
+                <a:solidFill>
+                  <a:srgbClr val="123F35"/>
+                </a:solidFill>
+              </a:defRPr>
+            </a:defPPr>
+            <a:lvl1pPr>
+              <a:defRPr sz="3600" b="1">
+                <a:solidFill>
+                  <a:srgbClr val="123F35"/>
+                </a:solidFill>
+              </a:defRPr>
+            </a:lvl1pPr>
+            <a:lvl2pPr>
+              <a:defRPr sz="3600" b="1">
+                <a:solidFill>
+                  <a:srgbClr val="123F35"/>
+                </a:solidFill>
+              </a:defRPr>
+            </a:lvl2pPr>
+            <a:lvl3pPr>
+              <a:defRPr sz="3600" b="1">
+                <a:solidFill>
+                  <a:srgbClr val="123F35"/>
+                </a:solidFill>
+              </a:defRPr>
+            </a:lvl3pPr>
+            <a:lvl4pPr>
+              <a:defRPr sz="3600" b="1">
+                <a:solidFill>
+                  <a:srgbClr val="123F35"/>
+                </a:solidFill>
+              </a:defRPr>
+            </a:lvl4pPr>
+            <a:lvl5pPr>
+              <a:defRPr sz="3600" b="1">
+                <a:solidFill>
+                  <a:srgbClr val="123F35"/>
+                </a:solidFill>
+              </a:defRPr>
+            </a:lvl5pPr>
+            <a:lvl6pPr>
+              <a:defRPr sz="3600" b="1">
+                <a:solidFill>
+                  <a:srgbClr val="123F35"/>
+                </a:solidFill>
+              </a:defRPr>
+            </a:lvl6pPr>
+            <a:lvl7pPr>
+              <a:defRPr sz="3600" b="1">
+                <a:solidFill>
+                  <a:srgbClr val="123F35"/>
+                </a:solidFill>
+              </a:defRPr>
+            </a:lvl7pPr>
+            <a:lvl8pPr>
+              <a:defRPr sz="3600" b="1">
+                <a:solidFill>
+                  <a:srgbClr val="123F35"/>
+                </a:solidFill>
+              </a:defRPr>
+            </a:lvl8pPr>
+            <a:lvl9pPr>
+              <a:defRPr sz="3600" b="1">
+                <a:solidFill>
+                  <a:srgbClr val="123F35"/>
+                </a:solidFill>
+              </a:defRPr>
+            </a:lvl9pPr>
+          </a:lstStyle>
+          <a:p xmlns:a="http://schemas.openxmlformats.org/drawingml/2006/main">
+            <a:pPr>
+              <a:defRPr sz="3600" b="1">
+                <a:solidFill>
+                  <a:srgbClr val="123F35"/>
+                </a:solidFill>
+              </a:defRPr>
+            </a:pPr>
+            <a:r>
+              <a:rPr sz="3600" b="1">
+                <a:solidFill>
+                  <a:srgbClr val="123F35"/>
+                </a:solidFill>
+              </a:rPr>
+              <a:t>Печать через Samba</a:t>
+            </a:r>
+          </a:p>
+        </p:txBody>
+      </p:sp>
+      <p:sp>
+        <p:nvSpPr>
+          <p:cNvPr id="2" name="">
+            <a:extLst xmlns:a="http://schemas.openxmlformats.org/drawingml/2006/main">
+              <a:ext uri="{FF2B5EF4-FFF2-40B4-BE49-F238E27FC236}">
+                <a16:creationId xmlns:a16="http://schemas.microsoft.com/office/drawing/2014/main" id="{9A55750E-0C10-4192-8121-5FBF7004B141}"/>
+              </a:ext>
+            </a:extLst>
+          </p:cNvPr>
+          <p:cNvSpPr>
+            <a:spLocks xmlns:a="http://schemas.openxmlformats.org/drawingml/2006/main" noGrp="1"/>
+          </p:cNvSpPr>
+          <p:nvPr/>
+        </p:nvSpPr>
+        <p:spPr>
+          <a:xfrm xmlns:a="http://schemas.openxmlformats.org/drawingml/2006/main">
+            <a:off x="685800" y="1809750"/>
+            <a:ext cx="4953000" cy="523875"/>
+          </a:xfrm>
+          <a:prstGeom xmlns:a="http://schemas.openxmlformats.org/drawingml/2006/main" prst="rect">
+            <a:avLst/>
+          </a:prstGeom>
+          <a:noFill xmlns:a="http://schemas.openxmlformats.org/drawingml/2006/main"/>
+          <a:ln xmlns:a="http://schemas.openxmlformats.org/drawingml/2006/main" w="0">
+            <a:noFill/>
+          </a:ln>
+        </p:spPr>
+        <p:txBody>
+          <a:bodyPr xmlns:a="http://schemas.openxmlformats.org/drawingml/2006/main"/>
+          <a:lstStyle xmlns:a="http://schemas.openxmlformats.org/drawingml/2006/main">
+            <a:defPPr>
+              <a:defRPr sz="2400" b="1">
+                <a:solidFill>
+                  <a:srgbClr val="203D36"/>
+                </a:solidFill>
+              </a:defRPr>
+            </a:defPPr>
+            <a:lvl1pPr>
+              <a:defRPr sz="2400" b="1">
+                <a:solidFill>
+                  <a:srgbClr val="203D36"/>
+                </a:solidFill>
+              </a:defRPr>
+            </a:lvl1pPr>
+            <a:lvl2pPr>
+              <a:defRPr sz="2400" b="1">
+                <a:solidFill>
+                  <a:srgbClr val="203D36"/>
+                </a:solidFill>
+              </a:defRPr>
+            </a:lvl2pPr>
+            <a:lvl3pPr>
+              <a:defRPr sz="2400" b="1">
+                <a:solidFill>
+                  <a:srgbClr val="203D36"/>
+                </a:solidFill>
+              </a:defRPr>
+            </a:lvl3pPr>
+            <a:lvl4pPr>
+              <a:defRPr sz="2400" b="1">
+                <a:solidFill>
+                  <a:srgbClr val="203D36"/>
+                </a:solidFill>
+              </a:defRPr>
+            </a:lvl4pPr>
+            <a:lvl5pPr>
+              <a:defRPr sz="2400" b="1">
+                <a:solidFill>
+                  <a:srgbClr val="203D36"/>
+                </a:solidFill>
+              </a:defRPr>
+            </a:lvl5pPr>
+            <a:lvl6pPr>
+              <a:defRPr sz="2400" b="1">
+                <a:solidFill>
+                  <a:srgbClr val="203D36"/>
+                </a:solidFill>
+              </a:defRPr>
+            </a:lvl6pPr>
+            <a:lvl7pPr>
+              <a:defRPr sz="2400" b="1">
+                <a:solidFill>
+                  <a:srgbClr val="203D36"/>
+                </a:solidFill>
+              </a:defRPr>
+            </a:lvl7pPr>
+            <a:lvl8pPr>
+              <a:defRPr sz="2400" b="1">
+                <a:solidFill>
+                  <a:srgbClr val="203D36"/>
+                </a:solidFill>
+              </a:defRPr>
+            </a:lvl8pPr>
+            <a:lvl9pPr>
+              <a:defRPr sz="2400" b="1">
+                <a:solidFill>
+                  <a:srgbClr val="203D36"/>
+                </a:solidFill>
+              </a:defRPr>
+            </a:lvl9pPr>
+          </a:lstStyle>
+          <a:p xmlns:a="http://schemas.openxmlformats.org/drawingml/2006/main">
+            <a:pPr>
+              <a:defRPr sz="2400" b="1">
+                <a:solidFill>
+                  <a:srgbClr val="203D36"/>
+                </a:solidFill>
+              </a:defRPr>
+            </a:pPr>
+            <a:r>
+              <a:rPr sz="2400" b="1">
+                <a:solidFill>
+                  <a:srgbClr val="203D36"/>
+                </a:solidFill>
+              </a:rPr>
+              <a:t>Samba → GoPrint</a:t>
+            </a:r>
+          </a:p>
+        </p:txBody>
+      </p:sp>
+      <p:sp>
+        <p:nvSpPr>
+          <p:cNvPr id="3" name="">
+            <a:extLst xmlns:a="http://schemas.openxmlformats.org/drawingml/2006/main">
+              <a:ext uri="{FF2B5EF4-FFF2-40B4-BE49-F238E27FC236}">
+                <a16:creationId xmlns:a16="http://schemas.microsoft.com/office/drawing/2014/main" id="{EDFF9120-B3B7-4043-A2E3-C9910A78973D}"/>
+              </a:ext>
+            </a:extLst>
+          </p:cNvPr>
+          <p:cNvSpPr>
+            <a:spLocks xmlns:a="http://schemas.openxmlformats.org/drawingml/2006/main" noGrp="1"/>
+          </p:cNvSpPr>
+          <p:nvPr/>
+        </p:nvSpPr>
+        <p:spPr>
+          <a:xfrm xmlns:a="http://schemas.openxmlformats.org/drawingml/2006/main">
+            <a:off x="685800" y="2476500"/>
+            <a:ext cx="5048250" cy="1524000"/>
+          </a:xfrm>
+          <a:prstGeom xmlns:a="http://schemas.openxmlformats.org/drawingml/2006/main" prst="rect">
+            <a:avLst/>
+          </a:prstGeom>
+          <a:noFill xmlns:a="http://schemas.openxmlformats.org/drawingml/2006/main"/>
+          <a:ln xmlns:a="http://schemas.openxmlformats.org/drawingml/2006/main" w="0">
+            <a:noFill/>
+          </a:ln>
+        </p:spPr>
+        <p:txBody>
+          <a:bodyPr xmlns:a="http://schemas.openxmlformats.org/drawingml/2006/main"/>
+          <a:lstStyle xmlns:a="http://schemas.openxmlformats.org/drawingml/2006/main">
+            <a:defPPr>
+              <a:defRPr sz="2100" b="0">
+                <a:solidFill>
+                  <a:srgbClr val="203D36"/>
+                </a:solidFill>
+              </a:defRPr>
+            </a:defPPr>
+            <a:lvl1pPr>
+              <a:defRPr sz="2100" b="0">
+                <a:solidFill>
+                  <a:srgbClr val="203D36"/>
+                </a:solidFill>
+              </a:defRPr>
+            </a:lvl1pPr>
+            <a:lvl2pPr>
+              <a:defRPr sz="2100" b="0">
+                <a:solidFill>
+                  <a:srgbClr val="203D36"/>
+                </a:solidFill>
+              </a:defRPr>
+            </a:lvl2pPr>
+            <a:lvl3pPr>
+              <a:defRPr sz="2100" b="0">
+                <a:solidFill>
+                  <a:srgbClr val="203D36"/>
+                </a:solidFill>
+              </a:defRPr>
+            </a:lvl3pPr>
+            <a:lvl4pPr>
+              <a:defRPr sz="2100" b="0">
+                <a:solidFill>
+                  <a:srgbClr val="203D36"/>
+                </a:solidFill>
+              </a:defRPr>
+            </a:lvl4pPr>
+            <a:lvl5pPr>
+              <a:defRPr sz="2100" b="0">
+                <a:solidFill>
+                  <a:srgbClr val="203D36"/>
+                </a:solidFill>
+              </a:defRPr>
+            </a:lvl5pPr>
+            <a:lvl6pPr>
+              <a:defRPr sz="2100" b="0">
+                <a:solidFill>
+                  <a:srgbClr val="203D36"/>
+                </a:solidFill>
+              </a:defRPr>
+            </a:lvl6pPr>
+            <a:lvl7pPr>
+              <a:defRPr sz="2100" b="0">
+                <a:solidFill>
+                  <a:srgbClr val="203D36"/>
+                </a:solidFill>
+              </a:defRPr>
+            </a:lvl7pPr>
+            <a:lvl8pPr>
+              <a:defRPr sz="2100" b="0">
+                <a:solidFill>
+                  <a:srgbClr val="203D36"/>
+                </a:solidFill>
+              </a:defRPr>
+            </a:lvl8pPr>
+            <a:lvl9pPr>
+              <a:defRPr sz="2100" b="0">
+                <a:solidFill>
+                  <a:srgbClr val="203D36"/>
+                </a:solidFill>
+              </a:defRPr>
+            </a:lvl9pPr>
+          </a:lstStyle>
+          <a:p xmlns:a="http://schemas.openxmlformats.org/drawingml/2006/main">
+            <a:pPr>
+              <a:defRPr sz="2100" b="0">
+                <a:solidFill>
+                  <a:srgbClr val="203D36"/>
+                </a:solidFill>
+              </a:defRPr>
+            </a:pPr>
+            <a:r>
+              <a:rPr sz="2100" b="0">
+                <a:solidFill>
+                  <a:srgbClr val="203D36"/>
+                </a:solidFill>
+              </a:rPr>
+              <a:t>Локальный Unix-мост проверяет UID,</a:t>
+            </a:r>
+          </a:p>
+          <a:p xmlns:a="http://schemas.openxmlformats.org/drawingml/2006/main">
+            <a:pPr>
+              <a:defRPr sz="2100" b="0">
+                <a:solidFill>
+                  <a:srgbClr val="203D36"/>
+                </a:solidFill>
+              </a:defRPr>
+            </a:pPr>
+            <a:r>
+              <a:rPr sz="2100" b="0">
+                <a:solidFill>
+                  <a:srgbClr val="203D36"/>
+                </a:solidFill>
+              </a:rPr>
+              <a:t>доменный UPN и права на принтер.</a:t>
+            </a:r>
+          </a:p>
+          <a:p xmlns:a="http://schemas.openxmlformats.org/drawingml/2006/main">
+            <a:pPr>
+              <a:defRPr sz="2100" b="0">
+                <a:solidFill>
+                  <a:srgbClr val="203D36"/>
+                </a:solidFill>
+              </a:defRPr>
+            </a:pPr>
+            <a:r>
+              <a:rPr sz="2100" b="0">
+                <a:solidFill>
+                  <a:srgbClr val="203D36"/>
+                </a:solidFill>
+              </a:rPr>
+              <a:t>Сохраняет автора и Follow Me.</a:t>
+            </a:r>
+          </a:p>
+        </p:txBody>
+      </p:sp>
+      <p:sp>
+        <p:nvSpPr>
+          <p:cNvPr id="4" name="">
+            <a:extLst xmlns:a="http://schemas.openxmlformats.org/drawingml/2006/main">
+              <a:ext uri="{FF2B5EF4-FFF2-40B4-BE49-F238E27FC236}">
+                <a16:creationId xmlns:a16="http://schemas.microsoft.com/office/drawing/2014/main" id="{ACAC175A-1259-4538-ACE2-6315039EFD20}"/>
+              </a:ext>
+            </a:extLst>
+          </p:cNvPr>
+          <p:cNvSpPr>
+            <a:spLocks xmlns:a="http://schemas.openxmlformats.org/drawingml/2006/main" noGrp="1"/>
+          </p:cNvSpPr>
+          <p:nvPr/>
+        </p:nvSpPr>
+        <p:spPr>
+          <a:xfrm xmlns:a="http://schemas.openxmlformats.org/drawingml/2006/main">
+            <a:off x="685800" y="4191000"/>
+            <a:ext cx="5048250" cy="476250"/>
+          </a:xfrm>
+          <a:prstGeom xmlns:a="http://schemas.openxmlformats.org/drawingml/2006/main" prst="rect">
+            <a:avLst/>
+          </a:prstGeom>
+          <a:noFill xmlns:a="http://schemas.openxmlformats.org/drawingml/2006/main"/>
+          <a:ln xmlns:a="http://schemas.openxmlformats.org/drawingml/2006/main" w="0">
+            <a:noFill/>
+          </a:ln>
+        </p:spPr>
+        <p:txBody>
+          <a:bodyPr xmlns:a="http://schemas.openxmlformats.org/drawingml/2006/main"/>
+          <a:lstStyle xmlns:a="http://schemas.openxmlformats.org/drawingml/2006/main">
+            <a:defPPr>
+              <a:defRPr sz="2400" b="1">
+                <a:solidFill>
+                  <a:srgbClr val="203D36"/>
+                </a:solidFill>
+              </a:defRPr>
+            </a:defPPr>
+            <a:lvl1pPr>
+              <a:defRPr sz="2400" b="1">
+                <a:solidFill>
+                  <a:srgbClr val="203D36"/>
+                </a:solidFill>
+              </a:defRPr>
+            </a:lvl1pPr>
+            <a:lvl2pPr>
+              <a:defRPr sz="2400" b="1">
+                <a:solidFill>
+                  <a:srgbClr val="203D36"/>
+                </a:solidFill>
+              </a:defRPr>
+            </a:lvl2pPr>
+            <a:lvl3pPr>
+              <a:defRPr sz="2400" b="1">
+                <a:solidFill>
+                  <a:srgbClr val="203D36"/>
+                </a:solidFill>
+              </a:defRPr>
+            </a:lvl3pPr>
+            <a:lvl4pPr>
+              <a:defRPr sz="2400" b="1">
+                <a:solidFill>
+                  <a:srgbClr val="203D36"/>
+                </a:solidFill>
+              </a:defRPr>
+            </a:lvl4pPr>
+            <a:lvl5pPr>
+              <a:defRPr sz="2400" b="1">
+                <a:solidFill>
+                  <a:srgbClr val="203D36"/>
+                </a:solidFill>
+              </a:defRPr>
+            </a:lvl5pPr>
+            <a:lvl6pPr>
+              <a:defRPr sz="2400" b="1">
+                <a:solidFill>
+                  <a:srgbClr val="203D36"/>
+                </a:solidFill>
+              </a:defRPr>
+            </a:lvl6pPr>
+            <a:lvl7pPr>
+              <a:defRPr sz="2400" b="1">
+                <a:solidFill>
+                  <a:srgbClr val="203D36"/>
+                </a:solidFill>
+              </a:defRPr>
+            </a:lvl7pPr>
+            <a:lvl8pPr>
+              <a:defRPr sz="2400" b="1">
+                <a:solidFill>
+                  <a:srgbClr val="203D36"/>
+                </a:solidFill>
+              </a:defRPr>
+            </a:lvl8pPr>
+            <a:lvl9pPr>
+              <a:defRPr sz="2400" b="1">
+                <a:solidFill>
+                  <a:srgbClr val="203D36"/>
+                </a:solidFill>
+              </a:defRPr>
+            </a:lvl9pPr>
+          </a:lstStyle>
+          <a:p xmlns:a="http://schemas.openxmlformats.org/drawingml/2006/main">
+            <a:pPr>
+              <a:defRPr sz="2400" b="1">
+                <a:solidFill>
+                  <a:srgbClr val="203D36"/>
+                </a:solidFill>
+              </a:defRPr>
+            </a:pPr>
+            <a:r>
+              <a:rPr sz="2400" b="1">
+                <a:solidFill>
+                  <a:srgbClr val="203D36"/>
+                </a:solidFill>
+              </a:rPr>
+              <a:t>GoPrint → Samba</a:t>
+            </a:r>
+          </a:p>
+        </p:txBody>
+      </p:sp>
+      <p:sp>
+        <p:nvSpPr>
+          <p:cNvPr id="5" name="">
+            <a:extLst xmlns:a="http://schemas.openxmlformats.org/drawingml/2006/main">
+              <a:ext uri="{FF2B5EF4-FFF2-40B4-BE49-F238E27FC236}">
+                <a16:creationId xmlns:a16="http://schemas.microsoft.com/office/drawing/2014/main" id="{DA814D3A-68A8-4FEA-8041-C6A0AC7CF410}"/>
+              </a:ext>
+            </a:extLst>
+          </p:cNvPr>
+          <p:cNvSpPr>
+            <a:spLocks xmlns:a="http://schemas.openxmlformats.org/drawingml/2006/main" noGrp="1"/>
+          </p:cNvSpPr>
+          <p:nvPr/>
+        </p:nvSpPr>
+        <p:spPr>
+          <a:xfrm xmlns:a="http://schemas.openxmlformats.org/drawingml/2006/main">
+            <a:off x="685800" y="4810125"/>
+            <a:ext cx="5238750" cy="1381125"/>
+          </a:xfrm>
+          <a:prstGeom xmlns:a="http://schemas.openxmlformats.org/drawingml/2006/main" prst="rect">
+            <a:avLst/>
+          </a:prstGeom>
+          <a:noFill xmlns:a="http://schemas.openxmlformats.org/drawingml/2006/main"/>
+          <a:ln xmlns:a="http://schemas.openxmlformats.org/drawingml/2006/main" w="0">
+            <a:noFill/>
+          </a:ln>
+        </p:spPr>
+        <p:txBody>
+          <a:bodyPr xmlns:a="http://schemas.openxmlformats.org/drawingml/2006/main"/>
+          <a:lstStyle xmlns:a="http://schemas.openxmlformats.org/drawingml/2006/main">
+            <a:defPPr>
+              <a:defRPr sz="2100" b="0">
+                <a:solidFill>
+                  <a:srgbClr val="203D36"/>
+                </a:solidFill>
+              </a:defRPr>
+            </a:defPPr>
+            <a:lvl1pPr>
+              <a:defRPr sz="2100" b="0">
+                <a:solidFill>
+                  <a:srgbClr val="203D36"/>
+                </a:solidFill>
+              </a:defRPr>
+            </a:lvl1pPr>
+            <a:lvl2pPr>
+              <a:defRPr sz="2100" b="0">
+                <a:solidFill>
+                  <a:srgbClr val="203D36"/>
+                </a:solidFill>
+              </a:defRPr>
+            </a:lvl2pPr>
+            <a:lvl3pPr>
+              <a:defRPr sz="2100" b="0">
+                <a:solidFill>
+                  <a:srgbClr val="203D36"/>
+                </a:solidFill>
+              </a:defRPr>
+            </a:lvl3pPr>
+            <a:lvl4pPr>
+              <a:defRPr sz="2100" b="0">
+                <a:solidFill>
+                  <a:srgbClr val="203D36"/>
+                </a:solidFill>
+              </a:defRPr>
+            </a:lvl4pPr>
+            <a:lvl5pPr>
+              <a:defRPr sz="2100" b="0">
+                <a:solidFill>
+                  <a:srgbClr val="203D36"/>
+                </a:solidFill>
+              </a:defRPr>
+            </a:lvl5pPr>
+            <a:lvl6pPr>
+              <a:defRPr sz="2100" b="0">
+                <a:solidFill>
+                  <a:srgbClr val="203D36"/>
+                </a:solidFill>
+              </a:defRPr>
+            </a:lvl6pPr>
+            <a:lvl7pPr>
+              <a:defRPr sz="2100" b="0">
+                <a:solidFill>
+                  <a:srgbClr val="203D36"/>
+                </a:solidFill>
+              </a:defRPr>
+            </a:lvl7pPr>
+            <a:lvl8pPr>
+              <a:defRPr sz="2100" b="0">
+                <a:solidFill>
+                  <a:srgbClr val="203D36"/>
+                </a:solidFill>
+              </a:defRPr>
+            </a:lvl8pPr>
+            <a:lvl9pPr>
+              <a:defRPr sz="2100" b="0">
+                <a:solidFill>
+                  <a:srgbClr val="203D36"/>
+                </a:solidFill>
+              </a:defRPr>
+            </a:lvl9pPr>
+          </a:lstStyle>
+          <a:p xmlns:a="http://schemas.openxmlformats.org/drawingml/2006/main">
+            <a:pPr>
+              <a:defRPr sz="2100" b="0">
+                <a:solidFill>
+                  <a:srgbClr val="203D36"/>
+                </a:solidFill>
+              </a:defRPr>
+            </a:pPr>
+            <a:r>
+              <a:rPr sz="2100" b="0">
+                <a:solidFill>
+                  <a:srgbClr val="203D36"/>
+                </a:solidFill>
+              </a:rPr>
+              <a:t>SMB3 с шифрованием и отдельной</a:t>
+            </a:r>
+          </a:p>
+          <a:p xmlns:a="http://schemas.openxmlformats.org/drawingml/2006/main">
+            <a:pPr>
+              <a:defRPr sz="2100" b="0">
+                <a:solidFill>
+                  <a:srgbClr val="203D36"/>
+                </a:solidFill>
+              </a:defRPr>
+            </a:pPr>
+            <a:r>
+              <a:rPr sz="2100" b="0">
+                <a:solidFill>
+                  <a:srgbClr val="203D36"/>
+                </a:solidFill>
+              </a:rPr>
+              <a:t>служебной учётной записью.</a:t>
+            </a:r>
+          </a:p>
+          <a:p xmlns:a="http://schemas.openxmlformats.org/drawingml/2006/main">
+            <a:pPr>
+              <a:defRPr sz="2100" b="0">
+                <a:solidFill>
+                  <a:srgbClr val="203D36"/>
+                </a:solidFill>
+              </a:defRPr>
+            </a:pPr>
+            <a:r>
+              <a:rPr sz="2100" b="0">
+                <a:solidFill>
+                  <a:srgbClr val="203D36"/>
+                </a:solidFill>
+              </a:rPr>
+              <a:t>PPD и политики выполняются в GoPrint.</a:t>
+            </a:r>
+          </a:p>
+        </p:txBody>
+      </p:sp>
+      <p:pic>
+        <p:nvPicPr>
+          <p:cNvPr id="6" name="">
+            <a:extLst xmlns:a="http://schemas.openxmlformats.org/drawingml/2006/main">
+              <a:ext uri="{FF2B5EF4-FFF2-40B4-BE49-F238E27FC236}">
+                <a16:creationId xmlns:a16="http://schemas.microsoft.com/office/drawing/2014/main" id="{2C7E5BBB-40D9-41C8-892D-FFF47CA21654}"/>
+              </a:ext>
+            </a:extLst>
+          </p:cNvPr>
+          <p:cNvPicPr>
+            <a:picLocks xmlns:a="http://schemas.openxmlformats.org/drawingml/2006/main" noChangeAspect="1"/>
+          </p:cNvPicPr>
+          <p:nvPr/>
+        </p:nvPicPr>
+        <p:blipFill>
+          <a:blip xmlns:r="http://schemas.openxmlformats.org/officeDocument/2006/relationships" xmlns:a="http://schemas.openxmlformats.org/drawingml/2006/main" r:embed="R6bf638c4dce1442c"/>
+          <a:stretch xmlns:a="http://schemas.openxmlformats.org/drawingml/2006/main"/>
+        </p:blipFill>
+        <p:spPr>
+          <a:xfrm xmlns:a="http://schemas.openxmlformats.org/drawingml/2006/main">
+            <a:off x="6381750" y="2172891"/>
+            <a:ext cx="5143500" cy="2893219"/>
+          </a:xfrm>
+          <a:prstGeom xmlns:a="http://schemas.openxmlformats.org/drawingml/2006/main" prst="rect">
+            <a:avLst/>
+          </a:prstGeom>
+        </p:spPr>
+      </p:pic>
+      <p:sp>
+        <p:nvSpPr>
+          <p:cNvPr id="7" name="">
+            <a:extLst xmlns:a="http://schemas.openxmlformats.org/drawingml/2006/main">
+              <a:ext uri="{FF2B5EF4-FFF2-40B4-BE49-F238E27FC236}">
+                <a16:creationId xmlns:a16="http://schemas.microsoft.com/office/drawing/2014/main" id="{3AAAAA23-3033-4B6E-B176-544060C3B3FF}"/>
+              </a:ext>
+            </a:extLst>
+          </p:cNvPr>
+          <p:cNvSpPr>
+            <a:spLocks xmlns:a="http://schemas.openxmlformats.org/drawingml/2006/main" noGrp="1"/>
+          </p:cNvSpPr>
+          <p:nvPr/>
+        </p:nvSpPr>
+        <p:spPr>
+          <a:xfrm xmlns:a="http://schemas.openxmlformats.org/drawingml/2006/main">
+            <a:off x="6381750" y="5619750"/>
+            <a:ext cx="5143500" cy="714375"/>
+          </a:xfrm>
+          <a:prstGeom xmlns:a="http://schemas.openxmlformats.org/drawingml/2006/main" prst="rect">
+            <a:avLst/>
+          </a:prstGeom>
+          <a:noFill xmlns:a="http://schemas.openxmlformats.org/drawingml/2006/main"/>
+          <a:ln xmlns:a="http://schemas.openxmlformats.org/drawingml/2006/main" w="0">
+            <a:noFill/>
+          </a:ln>
+        </p:spPr>
+        <p:txBody>
+          <a:bodyPr xmlns:a="http://schemas.openxmlformats.org/drawingml/2006/main"/>
+          <a:lstStyle xmlns:a="http://schemas.openxmlformats.org/drawingml/2006/main">
+            <a:defPPr>
+              <a:defRPr sz="1650" b="0">
+                <a:solidFill>
+                  <a:srgbClr val="587267"/>
+                </a:solidFill>
+              </a:defRPr>
+            </a:defPPr>
+            <a:lvl1pPr>
+              <a:defRPr sz="1650" b="0">
+                <a:solidFill>
+                  <a:srgbClr val="587267"/>
+                </a:solidFill>
+              </a:defRPr>
+            </a:lvl1pPr>
+            <a:lvl2pPr>
+              <a:defRPr sz="1650" b="0">
+                <a:solidFill>
+                  <a:srgbClr val="587267"/>
+                </a:solidFill>
+              </a:defRPr>
+            </a:lvl2pPr>
+            <a:lvl3pPr>
+              <a:defRPr sz="1650" b="0">
+                <a:solidFill>
+                  <a:srgbClr val="587267"/>
+                </a:solidFill>
+              </a:defRPr>
+            </a:lvl3pPr>
+            <a:lvl4pPr>
+              <a:defRPr sz="1650" b="0">
+                <a:solidFill>
+                  <a:srgbClr val="587267"/>
+                </a:solidFill>
+              </a:defRPr>
+            </a:lvl4pPr>
+            <a:lvl5pPr>
+              <a:defRPr sz="1650" b="0">
+                <a:solidFill>
+                  <a:srgbClr val="587267"/>
+                </a:solidFill>
+              </a:defRPr>
+            </a:lvl5pPr>
+            <a:lvl6pPr>
+              <a:defRPr sz="1650" b="0">
+                <a:solidFill>
+                  <a:srgbClr val="587267"/>
+                </a:solidFill>
+              </a:defRPr>
+            </a:lvl6pPr>
+            <a:lvl7pPr>
+              <a:defRPr sz="1650" b="0">
+                <a:solidFill>
+                  <a:srgbClr val="587267"/>
+                </a:solidFill>
+              </a:defRPr>
+            </a:lvl7pPr>
+            <a:lvl8pPr>
+              <a:defRPr sz="1650" b="0">
+                <a:solidFill>
+                  <a:srgbClr val="587267"/>
+                </a:solidFill>
+              </a:defRPr>
+            </a:lvl8pPr>
+            <a:lvl9pPr>
+              <a:defRPr sz="1650" b="0">
+                <a:solidFill>
+                  <a:srgbClr val="587267"/>
+                </a:solidFill>
+              </a:defRPr>
+            </a:lvl9pPr>
+          </a:lstStyle>
+          <a:p xmlns:a="http://schemas.openxmlformats.org/drawingml/2006/main">
+            <a:pPr>
+              <a:defRPr sz="1650" b="0">
+                <a:solidFill>
+                  <a:srgbClr val="587267"/>
+                </a:solidFill>
+              </a:defRPr>
+            </a:pPr>
+            <a:r>
+              <a:rPr sz="1650" b="0">
+                <a:solidFill>
+                  <a:srgbClr val="587267"/>
+                </a:solidFill>
+              </a:rPr>
+              <a:t>Служебный пароль хранится зашифрованным.</a:t>
+            </a:r>
+          </a:p>
+          <a:p xmlns:a="http://schemas.openxmlformats.org/drawingml/2006/main">
+            <a:pPr>
+              <a:defRPr sz="1650" b="0">
+                <a:solidFill>
+                  <a:srgbClr val="587267"/>
+                </a:solidFill>
+              </a:defRPr>
+            </a:pPr>
+            <a:r>
+              <a:rPr sz="1650" b="0">
+                <a:solidFill>
+                  <a:srgbClr val="587267"/>
+                </a:solidFill>
+              </a:rPr>
+              <a:t>Делегирование Kerberos пользователя не включено.</a:t>
+            </a:r>
+          </a:p>
+        </p:txBody>
+      </p:sp>
+      <p:sp>
+        <p:nvSpPr>
+          <p:cNvPr id="8" name="">
+            <a:extLst xmlns:a="http://schemas.openxmlformats.org/drawingml/2006/main">
+              <a:ext uri="{FF2B5EF4-FFF2-40B4-BE49-F238E27FC236}">
+                <a16:creationId xmlns:a16="http://schemas.microsoft.com/office/drawing/2014/main" id="{8B30C0AA-3E1B-4CA2-9D40-188D807CDA8E}"/>
+              </a:ext>
+            </a:extLst>
+          </p:cNvPr>
+          <p:cNvSpPr>
+            <a:spLocks xmlns:a="http://schemas.openxmlformats.org/drawingml/2006/main" noGrp="1"/>
+          </p:cNvSpPr>
+          <p:nvPr/>
+        </p:nvSpPr>
+        <p:spPr>
+          <a:xfrm xmlns:a="http://schemas.openxmlformats.org/drawingml/2006/main">
+            <a:off x="9667875" y="6381750"/>
+            <a:ext cx="2095500" cy="285750"/>
+          </a:xfrm>
+          <a:prstGeom xmlns:a="http://schemas.openxmlformats.org/drawingml/2006/main" prst="rect">
+            <a:avLst/>
+          </a:prstGeom>
+          <a:noFill xmlns:a="http://schemas.openxmlformats.org/drawingml/2006/main"/>
+          <a:ln xmlns:a="http://schemas.openxmlformats.org/drawingml/2006/main" w="0">
+            <a:noFill/>
+          </a:ln>
+        </p:spPr>
+        <p:txBody>
+          <a:bodyPr xmlns:a="http://schemas.openxmlformats.org/drawingml/2006/main"/>
+          <a:lstStyle xmlns:a="http://schemas.openxmlformats.org/drawingml/2006/main">
+            <a:defPPr>
+              <a:defRPr sz="1350" b="0">
+                <a:solidFill>
+                  <a:srgbClr val="587267"/>
+                </a:solidFill>
+              </a:defRPr>
+            </a:defPPr>
+            <a:lvl1pPr>
+              <a:defRPr sz="1350" b="0">
+                <a:solidFill>
+                  <a:srgbClr val="587267"/>
+                </a:solidFill>
+              </a:defRPr>
+            </a:lvl1pPr>
+            <a:lvl2pPr>
+              <a:defRPr sz="1350" b="0">
+                <a:solidFill>
+                  <a:srgbClr val="587267"/>
+                </a:solidFill>
+              </a:defRPr>
+            </a:lvl2pPr>
+            <a:lvl3pPr>
+              <a:defRPr sz="1350" b="0">
+                <a:solidFill>
+                  <a:srgbClr val="587267"/>
+                </a:solidFill>
+              </a:defRPr>
+            </a:lvl3pPr>
+            <a:lvl4pPr>
+              <a:defRPr sz="1350" b="0">
+                <a:solidFill>
+                  <a:srgbClr val="587267"/>
+                </a:solidFill>
+              </a:defRPr>
+            </a:lvl4pPr>
+            <a:lvl5pPr>
+              <a:defRPr sz="1350" b="0">
+                <a:solidFill>
+                  <a:srgbClr val="587267"/>
+                </a:solidFill>
+              </a:defRPr>
+            </a:lvl5pPr>
+            <a:lvl6pPr>
+              <a:defRPr sz="1350" b="0">
+                <a:solidFill>
+                  <a:srgbClr val="587267"/>
+                </a:solidFill>
+              </a:defRPr>
+            </a:lvl6pPr>
+            <a:lvl7pPr>
+              <a:defRPr sz="1350" b="0">
+                <a:solidFill>
+                  <a:srgbClr val="587267"/>
+                </a:solidFill>
+              </a:defRPr>
+            </a:lvl7pPr>
+            <a:lvl8pPr>
+              <a:defRPr sz="1350" b="0">
+                <a:solidFill>
+                  <a:srgbClr val="587267"/>
+                </a:solidFill>
+              </a:defRPr>
+            </a:lvl8pPr>
+            <a:lvl9pPr>
+              <a:defRPr sz="1350" b="0">
+                <a:solidFill>
+                  <a:srgbClr val="587267"/>
+                </a:solidFill>
+              </a:defRPr>
+            </a:lvl9pPr>
+          </a:lstStyle>
+          <a:p xmlns:a="http://schemas.openxmlformats.org/drawingml/2006/main">
+            <a:pPr>
+              <a:defRPr sz="1350" b="0">
+                <a:solidFill>
+                  <a:srgbClr val="587267"/>
+                </a:solidFill>
+              </a:defRPr>
+            </a:pPr>
+            <a:r>
+              <a:rPr sz="1350" b="0">
+                <a:solidFill>
+                  <a:srgbClr val="587267"/>
+                </a:solidFill>
+              </a:rPr>
+              <a:t>GoPrint  /  21</a:t>
+            </a:r>
+          </a:p>
+        </p:txBody>
+      </p:sp>
+    </p:spTree>
+    <p:extLst>
+      <p:ext uri="{BB962C8B-B14F-4D97-AF65-F5344CB8AC3E}">
+        <p14:creationId xmlns:p14="http://schemas.microsoft.com/office/powerpoint/2010/main" val="992213271"/>
+      </p:ext>
+    </p:extLst>
+  </p:cSld>
+</p:sld>
+</file>
+
+<file path=ppt/slides/slide22.xml><?xml version="1.0" encoding="utf-8"?>
+<p:sld xmlns:p="http://schemas.openxmlformats.org/presentationml/2006/main">
+  <p:cSld>
+    <p:bg>
+      <p:bgPr>
+        <a:solidFill xmlns:a="http://schemas.openxmlformats.org/drawingml/2006/main">
+          <a:srgbClr val="F5F7F3"/>
+        </a:solidFill>
+      </p:bgPr>
+    </p:bg>
+    <p:spTree>
+      <p:nvGrpSpPr>
+        <p:cNvPr id="1" name=""/>
+        <p:cNvGrpSpPr/>
+        <p:nvPr/>
+      </p:nvGrpSpPr>
+      <p:grpSpPr>
+        <a:xfrm xmlns:a="http://schemas.openxmlformats.org/drawingml/2006/main"/>
+      </p:grpSpPr>
+      <p:sp>
+        <p:nvSpPr>
           <p:cNvPr id="2" name="">
             <a:extLst xmlns:a="http://schemas.openxmlformats.org/drawingml/2006/main">
               <a:ext uri="{FF2B5EF4-FFF2-40B4-BE49-F238E27FC236}">
@@ -16078,7 +17131,7 @@
                   <a:srgbClr val="587267"/>
                 </a:solidFill>
               </a:rPr>
-              <a:t>GoPrint  /  21</a:t>
+              <a:t>GoPrint  /  22</a:t>
             </a:r>
           </a:p>
         </p:txBody>
@@ -16558,7 +17611,7 @@
                   <a:srgbClr val="203D36"/>
                 </a:solidFill>
               </a:rPr>
-              <a:t>SMB и USB · NTLM · WSD и поиск сканеров</a:t>
+              <a:t>USB · NTLM-вход в GoPrint · WSD и поиск сканеров</a:t>
             </a:r>
           </a:p>
           <a:p xmlns:a="http://schemas.openxmlformats.org/drawingml/2006/main">
@@ -16727,7 +17780,7 @@
 </p:sld>
 </file>
 
-<file path=ppt/slides/slide22.xml><?xml version="1.0" encoding="utf-8"?>
+<file path=ppt/slides/slide23.xml><?xml version="1.0" encoding="utf-8"?>
 <p:sld xmlns:p="http://schemas.openxmlformats.org/presentationml/2006/main">
   <p:cSld>
     <p:bg>
@@ -16981,7 +18034,7 @@
                   <a:srgbClr val="587267"/>
                 </a:solidFill>
               </a:rPr>
-              <a:t>GoPrint  /  22</a:t>
+              <a:t>GoPrint  /  23</a:t>
             </a:r>
           </a:p>
         </p:txBody>
@@ -19679,7 +20732,7 @@
                   <a:srgbClr val="203D36"/>
                 </a:solidFill>
               </a:rPr>
-              <a:t>Передача через IPP/IPPS или JetDirect; результат виден в очереди.</a:t>
+              <a:t>Передача через IPP/IPPS, JetDirect или SMB3; результат виден в очереди.</a:t>
             </a:r>
           </a:p>
         </p:txBody>
@@ -19699,7 +20752,7 @@
           <p:nvPr/>
         </p:nvPicPr>
         <p:blipFill>
-          <a:blip xmlns:r="http://schemas.openxmlformats.org/officeDocument/2006/relationships" xmlns:a="http://schemas.openxmlformats.org/drawingml/2006/main" r:embed="R5acab4d8e5694329"/>
+          <a:blip xmlns:r="http://schemas.openxmlformats.org/officeDocument/2006/relationships" xmlns:a="http://schemas.openxmlformats.org/drawingml/2006/main" r:embed="R8b0e24b591564b89"/>
           <a:srcRect xmlns:a="http://schemas.openxmlformats.org/drawingml/2006/main" l="0" t="0" r="0" b="0"/>
           <a:stretch xmlns:a="http://schemas.openxmlformats.org/drawingml/2006/main"/>
         </p:blipFill>
@@ -20477,7 +21530,7 @@
           <p:nvPr/>
         </p:nvPicPr>
         <p:blipFill>
-          <a:blip xmlns:r="http://schemas.openxmlformats.org/officeDocument/2006/relationships" xmlns:a="http://schemas.openxmlformats.org/drawingml/2006/main" r:embed="R16a4254988b64292"/>
+          <a:blip xmlns:r="http://schemas.openxmlformats.org/officeDocument/2006/relationships" xmlns:a="http://schemas.openxmlformats.org/drawingml/2006/main" r:embed="R6e2be106e7564284"/>
           <a:stretch xmlns:a="http://schemas.openxmlformats.org/drawingml/2006/main"/>
         </p:blipFill>
         <p:spPr>
@@ -21134,7 +22187,7 @@
           <p:nvPr/>
         </p:nvPicPr>
         <p:blipFill>
-          <a:blip xmlns:r="http://schemas.openxmlformats.org/officeDocument/2006/relationships" xmlns:a="http://schemas.openxmlformats.org/drawingml/2006/main" r:embed="R0b03150671754c2b"/>
+          <a:blip xmlns:r="http://schemas.openxmlformats.org/officeDocument/2006/relationships" xmlns:a="http://schemas.openxmlformats.org/drawingml/2006/main" r:embed="R99bb62a3d1564b24"/>
           <a:stretch xmlns:a="http://schemas.openxmlformats.org/drawingml/2006/main"/>
         </p:blipFill>
         <p:spPr>
@@ -21842,7 +22895,7 @@
           <p:nvPr/>
         </p:nvPicPr>
         <p:blipFill>
-          <a:blip xmlns:r="http://schemas.openxmlformats.org/officeDocument/2006/relationships" xmlns:a="http://schemas.openxmlformats.org/drawingml/2006/main" r:embed="R8c6aa76fde9a46b8"/>
+          <a:blip xmlns:r="http://schemas.openxmlformats.org/officeDocument/2006/relationships" xmlns:a="http://schemas.openxmlformats.org/drawingml/2006/main" r:embed="R467102af93df45ee"/>
           <a:stretch xmlns:a="http://schemas.openxmlformats.org/drawingml/2006/main"/>
         </p:blipFill>
         <p:spPr>
@@ -22139,7 +23192,7 @@
           <p:nvPr/>
         </p:nvPicPr>
         <p:blipFill>
-          <a:blip xmlns:r="http://schemas.openxmlformats.org/officeDocument/2006/relationships" xmlns:a="http://schemas.openxmlformats.org/drawingml/2006/main" r:embed="R9c0d557d8b664522"/>
+          <a:blip xmlns:r="http://schemas.openxmlformats.org/officeDocument/2006/relationships" xmlns:a="http://schemas.openxmlformats.org/drawingml/2006/main" r:embed="R79732494f5014e56"/>
           <a:stretch xmlns:a="http://schemas.openxmlformats.org/drawingml/2006/main"/>
         </p:blipFill>
         <p:spPr>
@@ -23584,7 +24637,7 @@
           <p:nvPr/>
         </p:nvPicPr>
         <p:blipFill>
-          <a:blip xmlns:r="http://schemas.openxmlformats.org/officeDocument/2006/relationships" xmlns:a="http://schemas.openxmlformats.org/drawingml/2006/main" r:embed="Rde658cd92dfb4532"/>
+          <a:blip xmlns:r="http://schemas.openxmlformats.org/officeDocument/2006/relationships" xmlns:a="http://schemas.openxmlformats.org/drawingml/2006/main" r:embed="Rb8785c318f58452f"/>
           <a:stretch xmlns:a="http://schemas.openxmlformats.org/drawingml/2006/main"/>
         </p:blipFill>
         <p:spPr>

</xml_diff>